<commit_message>
updated poster according to requirements
</commit_message>
<xml_diff>
--- a/Project Poster - Weather App.pptx
+++ b/Project Poster - Weather App.pptx
@@ -243,7 +243,7 @@
           <a:p>
             <a:fld id="{96F86DA2-6F35-4111-ACB3-E2300C0C7C15}" type="datetimeFigureOut">
               <a:rPr lang="en-GB" smtClean="0"/>
-              <a:t>03/06/2026</a:t>
+              <a:t>18/06/2026</a:t>
             </a:fld>
             <a:endParaRPr lang="en-GB"/>
           </a:p>
@@ -413,7 +413,7 @@
           <a:p>
             <a:fld id="{96F86DA2-6F35-4111-ACB3-E2300C0C7C15}" type="datetimeFigureOut">
               <a:rPr lang="en-GB" smtClean="0"/>
-              <a:t>03/06/2026</a:t>
+              <a:t>18/06/2026</a:t>
             </a:fld>
             <a:endParaRPr lang="en-GB"/>
           </a:p>
@@ -593,7 +593,7 @@
           <a:p>
             <a:fld id="{96F86DA2-6F35-4111-ACB3-E2300C0C7C15}" type="datetimeFigureOut">
               <a:rPr lang="en-GB" smtClean="0"/>
-              <a:t>03/06/2026</a:t>
+              <a:t>18/06/2026</a:t>
             </a:fld>
             <a:endParaRPr lang="en-GB"/>
           </a:p>
@@ -763,7 +763,7 @@
           <a:p>
             <a:fld id="{96F86DA2-6F35-4111-ACB3-E2300C0C7C15}" type="datetimeFigureOut">
               <a:rPr lang="en-GB" smtClean="0"/>
-              <a:t>03/06/2026</a:t>
+              <a:t>18/06/2026</a:t>
             </a:fld>
             <a:endParaRPr lang="en-GB"/>
           </a:p>
@@ -1007,7 +1007,7 @@
           <a:p>
             <a:fld id="{96F86DA2-6F35-4111-ACB3-E2300C0C7C15}" type="datetimeFigureOut">
               <a:rPr lang="en-GB" smtClean="0"/>
-              <a:t>03/06/2026</a:t>
+              <a:t>18/06/2026</a:t>
             </a:fld>
             <a:endParaRPr lang="en-GB"/>
           </a:p>
@@ -1239,7 +1239,7 @@
           <a:p>
             <a:fld id="{96F86DA2-6F35-4111-ACB3-E2300C0C7C15}" type="datetimeFigureOut">
               <a:rPr lang="en-GB" smtClean="0"/>
-              <a:t>03/06/2026</a:t>
+              <a:t>18/06/2026</a:t>
             </a:fld>
             <a:endParaRPr lang="en-GB"/>
           </a:p>
@@ -1606,7 +1606,7 @@
           <a:p>
             <a:fld id="{96F86DA2-6F35-4111-ACB3-E2300C0C7C15}" type="datetimeFigureOut">
               <a:rPr lang="en-GB" smtClean="0"/>
-              <a:t>03/06/2026</a:t>
+              <a:t>18/06/2026</a:t>
             </a:fld>
             <a:endParaRPr lang="en-GB"/>
           </a:p>
@@ -1724,7 +1724,7 @@
           <a:p>
             <a:fld id="{96F86DA2-6F35-4111-ACB3-E2300C0C7C15}" type="datetimeFigureOut">
               <a:rPr lang="en-GB" smtClean="0"/>
-              <a:t>03/06/2026</a:t>
+              <a:t>18/06/2026</a:t>
             </a:fld>
             <a:endParaRPr lang="en-GB"/>
           </a:p>
@@ -1819,7 +1819,7 @@
           <a:p>
             <a:fld id="{96F86DA2-6F35-4111-ACB3-E2300C0C7C15}" type="datetimeFigureOut">
               <a:rPr lang="en-GB" smtClean="0"/>
-              <a:t>03/06/2026</a:t>
+              <a:t>18/06/2026</a:t>
             </a:fld>
             <a:endParaRPr lang="en-GB"/>
           </a:p>
@@ -2096,7 +2096,7 @@
           <a:p>
             <a:fld id="{96F86DA2-6F35-4111-ACB3-E2300C0C7C15}" type="datetimeFigureOut">
               <a:rPr lang="en-GB" smtClean="0"/>
-              <a:t>03/06/2026</a:t>
+              <a:t>18/06/2026</a:t>
             </a:fld>
             <a:endParaRPr lang="en-GB"/>
           </a:p>
@@ -2353,7 +2353,7 @@
           <a:p>
             <a:fld id="{96F86DA2-6F35-4111-ACB3-E2300C0C7C15}" type="datetimeFigureOut">
               <a:rPr lang="en-GB" smtClean="0"/>
-              <a:t>03/06/2026</a:t>
+              <a:t>18/06/2026</a:t>
             </a:fld>
             <a:endParaRPr lang="en-GB"/>
           </a:p>
@@ -2566,7 +2566,7 @@
           <a:p>
             <a:fld id="{96F86DA2-6F35-4111-ACB3-E2300C0C7C15}" type="datetimeFigureOut">
               <a:rPr lang="en-GB" smtClean="0"/>
-              <a:t>03/06/2026</a:t>
+              <a:t>18/06/2026</a:t>
             </a:fld>
             <a:endParaRPr lang="en-GB"/>
           </a:p>
@@ -3313,8 +3313,8 @@
         </p:nvSpPr>
         <p:spPr>
           <a:xfrm>
-            <a:off x="818147" y="4478213"/>
-            <a:ext cx="13343330" cy="5462955"/>
+            <a:off x="818147" y="4599345"/>
+            <a:ext cx="13258640" cy="7369821"/>
           </a:xfrm>
           <a:prstGeom prst="roundRect">
             <a:avLst/>
@@ -3349,46 +3349,53 @@
           <a:lstStyle/>
           <a:p>
             <a:r>
-              <a:rPr lang="en-US" sz="3600" dirty="0">
+              <a:rPr sz="4000" b="1" dirty="0">
                 <a:solidFill>
                   <a:schemeClr val="tx1"/>
                 </a:solidFill>
               </a:rPr>
-              <a:t>1. </a:t>
-            </a:r>
-            <a:r>
-              <a:rPr lang="en-US" sz="3600" b="1" dirty="0">
+              <a:t>1. Introduction</a:t>
+            </a:r>
+          </a:p>
+          <a:p>
+            <a:r>
+              <a:rPr sz="3200" b="0" dirty="0">
                 <a:solidFill>
                   <a:schemeClr val="tx1"/>
                 </a:solidFill>
               </a:rPr>
-              <a:t>Introduction</a:t>
-            </a:r>
-          </a:p>
-          <a:p>
-            <a:r>
-              <a:rPr lang="en-US" sz="3600" dirty="0">
+              <a:t>• Overview: This project presents a high-performance, reactive Android Weather Application built with Kotlin. The app provides real-time meteorological data, 5-day forecasts, and detailed Air Quality Index (AQI) reports.</a:t>
+            </a:r>
+          </a:p>
+          <a:p>
+            <a:r>
+              <a:rPr sz="3200" b="0" dirty="0">
                 <a:solidFill>
                   <a:schemeClr val="tx1"/>
                 </a:solidFill>
               </a:rPr>
-              <a:t>• Overview: This project presents a high-performance, reactive Android Weather Application built with Kotlin. The app provides users with real-time meteorological data, 5-day forecasts, and detailed Air Quality Index (AQI) reports.</a:t>
-            </a:r>
-          </a:p>
-          <a:p>
-            <a:r>
-              <a:rPr lang="en-US" sz="3600" dirty="0">
+              <a:t>• Purpose: To offer a clean, distraction-free tool for monitoring local weather, air quality, and saved favorite cities.</a:t>
+            </a:r>
+          </a:p>
+          <a:p>
+            <a:r>
+              <a:rPr sz="3200" b="0" dirty="0">
                 <a:solidFill>
                   <a:schemeClr val="tx1"/>
                 </a:solidFill>
               </a:rPr>
-              <a:t>• Core Objective: To leverage modern Android development standards to create a tool that is both "Offline-First" (via Room database) and highly responsive (via Coroutines and Flow).</a:t>
-            </a:r>
-            <a:endParaRPr lang="en-IL" sz="3600" dirty="0">
-              <a:solidFill>
-                <a:schemeClr val="tx1"/>
-              </a:solidFill>
-            </a:endParaRPr>
+              <a:t>• Target Audience: General mobile users, frequent travelers, and health-conscious individuals who need reliable at-a-glance environmental information.</a:t>
+            </a:r>
+          </a:p>
+          <a:p>
+            <a:r>
+              <a:rPr sz="3200" b="0" dirty="0">
+                <a:solidFill>
+                  <a:schemeClr val="tx1"/>
+                </a:solidFill>
+              </a:rPr>
+              <a:t>• Core Objective: Leverage modern Android standards to build an "Offline-First" app (Room database) that stays responsive via Coroutines and Flow.</a:t>
+            </a:r>
           </a:p>
         </p:txBody>
       </p:sp>
@@ -3406,8 +3413,8 @@
         </p:nvSpPr>
         <p:spPr>
           <a:xfrm>
-            <a:off x="818147" y="10190281"/>
-            <a:ext cx="13343330" cy="7147558"/>
+            <a:off x="733457" y="12447639"/>
+            <a:ext cx="13343330" cy="8282070"/>
           </a:xfrm>
           <a:prstGeom prst="roundRect">
             <a:avLst/>
@@ -3442,33 +3449,25 @@
           <a:lstStyle/>
           <a:p>
             <a:r>
-              <a:rPr lang="en-US" sz="3600" dirty="0">
+              <a:rPr sz="4000" b="1" dirty="0">
                 <a:solidFill>
                   <a:schemeClr val="tx1"/>
                 </a:solidFill>
               </a:rPr>
-              <a:t>2. </a:t>
-            </a:r>
-            <a:r>
-              <a:rPr lang="en-US" sz="3600" b="1" dirty="0">
+              <a:t>2. Technical Architecture &amp; Tech Stack</a:t>
+            </a:r>
+          </a:p>
+          <a:p>
+            <a:r>
+              <a:rPr sz="3200" b="0" dirty="0">
                 <a:solidFill>
                   <a:schemeClr val="tx1"/>
                 </a:solidFill>
               </a:rPr>
-              <a:t>Technical Architecture &amp; Tech Stack</a:t>
-            </a:r>
-          </a:p>
-          <a:p>
-            <a:r>
-              <a:rPr lang="en-US" sz="3600" dirty="0">
-                <a:solidFill>
-                  <a:schemeClr val="tx1"/>
-                </a:solidFill>
-              </a:rPr>
-              <a:t>• Architecture: The app strictly follows the MVVM (Model-View-</a:t>
-            </a:r>
-            <a:r>
-              <a:rPr lang="en-US" sz="3600" dirty="0" err="1">
+              <a:t>• Architecture: MVVM (Model-View-</a:t>
+            </a:r>
+            <a:r>
+              <a:rPr sz="3200" b="0" dirty="0" err="1">
                 <a:solidFill>
                   <a:schemeClr val="tx1"/>
                 </a:solidFill>
@@ -3476,37 +3475,69 @@
               <a:t>ViewModel</a:t>
             </a:r>
             <a:r>
-              <a:rPr lang="en-US" sz="3600" dirty="0">
+              <a:rPr sz="3200" b="0" dirty="0">
                 <a:solidFill>
                   <a:schemeClr val="tx1"/>
                 </a:solidFill>
               </a:rPr>
-              <a:t>) design pattern to ensure separation of concerns.</a:t>
-            </a:r>
-          </a:p>
-          <a:p>
-            <a:r>
-              <a:rPr lang="en-US" sz="3600" dirty="0">
+              <a:t>) with clear separation between UI, </a:t>
+            </a:r>
+            <a:r>
+              <a:rPr sz="3200" b="0" dirty="0" err="1">
                 <a:solidFill>
                   <a:schemeClr val="tx1"/>
                 </a:solidFill>
               </a:rPr>
-              <a:t>• Dependency Injection: Dagger-Hilt is used to manage object lifecycles, making the app modular and testable.</a:t>
-            </a:r>
-          </a:p>
-          <a:p>
-            <a:r>
-              <a:rPr lang="en-US" sz="3600" dirty="0">
+              <a:t>ViewModels</a:t>
+            </a:r>
+            <a:r>
+              <a:rPr sz="3200" b="0" dirty="0">
                 <a:solidFill>
                   <a:schemeClr val="tx1"/>
                 </a:solidFill>
               </a:rPr>
-              <a:t>• Data Strategy: A Repository Pattern acts as the "Single Source of Truth," coordinating data between the Retrofit network client and the Room local persistence layer.</a:t>
-            </a:r>
-          </a:p>
-          <a:p>
-            <a:r>
-              <a:rPr lang="en-US" sz="3600" dirty="0">
+              <a:t>, Repository, and data sources.</a:t>
+            </a:r>
+          </a:p>
+          <a:p>
+            <a:r>
+              <a:rPr sz="3200" b="0" dirty="0">
+                <a:solidFill>
+                  <a:schemeClr val="tx1"/>
+                </a:solidFill>
+              </a:rPr>
+              <a:t>• Dependency Injection: Dagger-Hilt manages object lifecycles for modular, testable code.</a:t>
+            </a:r>
+          </a:p>
+          <a:p>
+            <a:r>
+              <a:rPr sz="3200" b="0" dirty="0">
+                <a:solidFill>
+                  <a:schemeClr val="tx1"/>
+                </a:solidFill>
+              </a:rPr>
+              <a:t>• Data Strategy: Repository Pattern as the "Single Source of Truth" between Retrofit (</a:t>
+            </a:r>
+            <a:r>
+              <a:rPr sz="3200" b="0" dirty="0" err="1">
+                <a:solidFill>
+                  <a:schemeClr val="tx1"/>
+                </a:solidFill>
+              </a:rPr>
+              <a:t>OpenWeatherMap</a:t>
+            </a:r>
+            <a:r>
+              <a:rPr sz="3200" b="0" dirty="0">
+                <a:solidFill>
+                  <a:schemeClr val="tx1"/>
+                </a:solidFill>
+              </a:rPr>
+              <a:t> API) and Room local persistence.</a:t>
+            </a:r>
+          </a:p>
+          <a:p>
+            <a:r>
+              <a:rPr sz="3200" b="0" dirty="0">
                 <a:solidFill>
                   <a:schemeClr val="tx1"/>
                 </a:solidFill>
@@ -3514,7 +3545,7 @@
               <a:t>• Background Tasks: </a:t>
             </a:r>
             <a:r>
-              <a:rPr lang="en-US" sz="3600" dirty="0" err="1">
+              <a:rPr sz="3200" b="0" dirty="0" err="1">
                 <a:solidFill>
                   <a:schemeClr val="tx1"/>
                 </a:solidFill>
@@ -3522,18 +3553,81 @@
               <a:t>WorkManager</a:t>
             </a:r>
             <a:r>
-              <a:rPr lang="en-US" sz="3600" dirty="0">
+              <a:rPr sz="3200" b="0" dirty="0">
                 <a:solidFill>
                   <a:schemeClr val="tx1"/>
                 </a:solidFill>
               </a:rPr>
-              <a:t> is implemented to handle periodic weather updates in the background, ensuring data is fresh even when the app is closed.</a:t>
-            </a:r>
-            <a:endParaRPr lang="en-IL" sz="3600" dirty="0">
-              <a:solidFill>
-                <a:schemeClr val="tx1"/>
-              </a:solidFill>
-            </a:endParaRPr>
+              <a:t> performs periodic weather updates when the app is closed.</a:t>
+            </a:r>
+          </a:p>
+          <a:p>
+            <a:r>
+              <a:rPr sz="3200" b="0" dirty="0">
+                <a:solidFill>
+                  <a:schemeClr val="tx1"/>
+                </a:solidFill>
+              </a:rPr>
+              <a:t>• External Libraries: Retrofit, </a:t>
+            </a:r>
+            <a:r>
+              <a:rPr sz="3200" b="0" dirty="0" err="1">
+                <a:solidFill>
+                  <a:schemeClr val="tx1"/>
+                </a:solidFill>
+              </a:rPr>
+              <a:t>Gson</a:t>
+            </a:r>
+            <a:r>
+              <a:rPr sz="3200" b="0" dirty="0">
+                <a:solidFill>
+                  <a:schemeClr val="tx1"/>
+                </a:solidFill>
+              </a:rPr>
+              <a:t>, Room, Dagger-Hilt, Glide, </a:t>
+            </a:r>
+            <a:r>
+              <a:rPr sz="3200" b="0" dirty="0" err="1">
+                <a:solidFill>
+                  <a:schemeClr val="tx1"/>
+                </a:solidFill>
+              </a:rPr>
+              <a:t>WorkManager</a:t>
+            </a:r>
+            <a:r>
+              <a:rPr sz="3200" b="0" dirty="0">
+                <a:solidFill>
+                  <a:schemeClr val="tx1"/>
+                </a:solidFill>
+              </a:rPr>
+              <a:t>, Jetpack Navigation, Material 3, Google Play Location Services.</a:t>
+            </a:r>
+          </a:p>
+          <a:p>
+            <a:r>
+              <a:rPr sz="3200" b="0" dirty="0">
+                <a:solidFill>
+                  <a:schemeClr val="tx1"/>
+                </a:solidFill>
+              </a:rPr>
+              <a:t>• Key Methods: offline-first repository sync, </a:t>
+            </a:r>
+            <a:r>
+              <a:rPr sz="3200" b="0" dirty="0" err="1">
+                <a:solidFill>
+                  <a:schemeClr val="tx1"/>
+                </a:solidFill>
+              </a:rPr>
+              <a:t>ViewModel</a:t>
+            </a:r>
+            <a:r>
+              <a:rPr sz="3200" b="0" dirty="0">
+                <a:solidFill>
+                  <a:schemeClr val="tx1"/>
+                </a:solidFill>
+              </a:rPr>
+              <a:t> coroutine loading, GPS-based refresh, and background worker updates.</a:t>
+            </a:r>
           </a:p>
         </p:txBody>
       </p:sp>
@@ -3551,8 +3645,8 @@
         </p:nvSpPr>
         <p:spPr>
           <a:xfrm>
-            <a:off x="818147" y="17574667"/>
-            <a:ext cx="13343330" cy="6819166"/>
+            <a:off x="733457" y="21208181"/>
+            <a:ext cx="13343330" cy="5479876"/>
           </a:xfrm>
           <a:prstGeom prst="roundRect">
             <a:avLst/>
@@ -3587,7 +3681,7 @@
           <a:lstStyle/>
           <a:p>
             <a:r>
-              <a:rPr lang="en-US" sz="3600" dirty="0">
+              <a:rPr sz="4000" b="1" dirty="0">
                 <a:solidFill>
                   <a:schemeClr val="tx1"/>
                 </a:solidFill>
@@ -3597,75 +3691,45 @@
           </a:p>
           <a:p>
             <a:r>
-              <a:rPr lang="en-US" sz="3600" dirty="0">
+              <a:rPr sz="3200" b="0" dirty="0">
                 <a:solidFill>
                   <a:schemeClr val="tx1"/>
                 </a:solidFill>
               </a:rPr>
-              <a:t>• Navigation: The app utilizes the Jetpack Navigation Component with a single-activity architecture.</a:t>
-            </a:r>
-          </a:p>
-          <a:p>
-            <a:r>
-              <a:rPr lang="en-US" sz="3600" dirty="0">
+              <a:t>• Diagrams (right): Application screen-flow chart and MVVM / Repository architecture UML-style diagram with navigation paths and screenshots.</a:t>
+            </a:r>
+          </a:p>
+          <a:p>
+            <a:r>
+              <a:rPr sz="3200" b="0" dirty="0">
                 <a:solidFill>
                   <a:schemeClr val="tx1"/>
                 </a:solidFill>
               </a:rPr>
-              <a:t>• Key Modules:</a:t>
-            </a:r>
-          </a:p>
-          <a:p>
-            <a:r>
-              <a:rPr lang="en-US" sz="3600" dirty="0">
+              <a:t>• Navigation: Single-activity app using Jetpack Navigation Component and Material 3 bottom navigation.</a:t>
+            </a:r>
+          </a:p>
+          <a:p>
+            <a:r>
+              <a:rPr sz="3200" b="0" dirty="0">
                 <a:solidFill>
                   <a:schemeClr val="tx1"/>
                 </a:solidFill>
               </a:rPr>
-              <a:t>◦Home/Latest: Immediate current weather via Location Services.</a:t>
-            </a:r>
-          </a:p>
-          <a:p>
-            <a:r>
-              <a:rPr lang="en-US" sz="3600" dirty="0">
+              <a:t>• Key Modules: Home &amp; Latest (GPS weather), Forecast, Pollution (AQI / PM2.5 / NO₂), Favorites (Room), and Settings.</a:t>
+            </a:r>
+          </a:p>
+          <a:p>
+            <a:r>
+              <a:rPr sz="3200" b="0" dirty="0">
                 <a:solidFill>
                   <a:schemeClr val="tx1"/>
                 </a:solidFill>
               </a:rPr>
-              <a:t>◦Forecast: Interactive list of upcoming weather trends.</a:t>
-            </a:r>
-          </a:p>
-          <a:p>
-            <a:r>
-              <a:rPr lang="en-US" sz="3600" dirty="0">
-                <a:solidFill>
-                  <a:schemeClr val="tx1"/>
-                </a:solidFill>
-              </a:rPr>
-              <a:t>◦ Pollution: Environmental health metrics (PM2.5, NO2, etc.).</a:t>
-            </a:r>
-          </a:p>
-          <a:p>
-            <a:r>
-              <a:rPr lang="en-US" sz="3600" dirty="0">
-                <a:solidFill>
-                  <a:schemeClr val="tx1"/>
-                </a:solidFill>
-              </a:rPr>
-              <a:t>◦ Favorites: A personalized database of cities for quick access.</a:t>
-            </a:r>
-          </a:p>
-          <a:p>
-            <a:r>
-              <a:rPr lang="en-US" sz="3600" dirty="0">
-                <a:solidFill>
-                  <a:schemeClr val="tx1"/>
-                </a:solidFill>
-              </a:rPr>
-              <a:t>• UI/UX: Built using Material 3 design principles and </a:t>
-            </a:r>
-            <a:r>
-              <a:rPr lang="en-US" sz="3600" dirty="0" err="1">
+              <a:t>• UI/UX: Material 3 design, </a:t>
+            </a:r>
+            <a:r>
+              <a:rPr sz="3200" b="0" dirty="0" err="1">
                 <a:solidFill>
                   <a:schemeClr val="tx1"/>
                 </a:solidFill>
@@ -3673,18 +3737,29 @@
               <a:t>ViewBinding</a:t>
             </a:r>
             <a:r>
-              <a:rPr lang="en-US" sz="3600" dirty="0">
+              <a:rPr sz="3200" b="0" dirty="0">
                 <a:solidFill>
                   <a:schemeClr val="tx1"/>
                 </a:solidFill>
               </a:rPr>
-              <a:t> for efficient UI updates.</a:t>
-            </a:r>
-            <a:endParaRPr lang="en-IL" sz="3600" dirty="0">
-              <a:solidFill>
-                <a:schemeClr val="tx1"/>
-              </a:solidFill>
-            </a:endParaRPr>
+              <a:t>, and reactive UI updates via </a:t>
+            </a:r>
+            <a:r>
+              <a:rPr sz="3200" b="0" dirty="0" err="1">
+                <a:solidFill>
+                  <a:schemeClr val="tx1"/>
+                </a:solidFill>
+              </a:rPr>
+              <a:t>LiveData</a:t>
+            </a:r>
+            <a:r>
+              <a:rPr sz="3200" b="0" dirty="0">
+                <a:solidFill>
+                  <a:schemeClr val="tx1"/>
+                </a:solidFill>
+              </a:rPr>
+              <a:t> / Flow.</a:t>
+            </a:r>
           </a:p>
         </p:txBody>
       </p:sp>
@@ -3702,8 +3777,8 @@
         </p:nvSpPr>
         <p:spPr>
           <a:xfrm>
-            <a:off x="818147" y="24630661"/>
-            <a:ext cx="13343330" cy="6429442"/>
+            <a:off x="733457" y="27166528"/>
+            <a:ext cx="13343330" cy="4130401"/>
           </a:xfrm>
           <a:prstGeom prst="roundRect">
             <a:avLst/>
@@ -3738,43 +3813,35 @@
           <a:lstStyle/>
           <a:p>
             <a:r>
-              <a:rPr lang="en-US" sz="3600" dirty="0">
+              <a:rPr sz="4000" b="1" dirty="0">
                 <a:solidFill>
                   <a:schemeClr val="tx1"/>
                 </a:solidFill>
               </a:rPr>
-              <a:t>4. </a:t>
-            </a:r>
-            <a:r>
-              <a:rPr lang="en-US" sz="3600" b="1" dirty="0">
+              <a:t>4. Conclusions</a:t>
+            </a:r>
+          </a:p>
+          <a:p>
+            <a:r>
+              <a:rPr sz="3200" b="0" dirty="0">
                 <a:solidFill>
                   <a:schemeClr val="tx1"/>
                 </a:solidFill>
               </a:rPr>
-              <a:t>Conclusions</a:t>
-            </a:r>
-          </a:p>
-          <a:p>
-            <a:r>
-              <a:rPr lang="en-US" sz="3600" dirty="0">
+              <a:t>• Achieved Goals: Robust weather tracking with synchronized remote API data and local Room storage.</a:t>
+            </a:r>
+          </a:p>
+          <a:p>
+            <a:r>
+              <a:rPr sz="3200" b="0" dirty="0">
                 <a:solidFill>
                   <a:schemeClr val="tx1"/>
                 </a:solidFill>
               </a:rPr>
-              <a:t>• Achieved Goals: Successfully implemented a robust weather tracking system that synchronizes remote API data with a local database.</a:t>
-            </a:r>
-          </a:p>
-          <a:p>
-            <a:r>
-              <a:rPr lang="en-US" sz="3600" dirty="0">
-                <a:solidFill>
-                  <a:schemeClr val="tx1"/>
-                </a:solidFill>
-              </a:rPr>
-              <a:t>• Results: The app provides sub-second UI updates through reactive streams (</a:t>
-            </a:r>
-            <a:r>
-              <a:rPr lang="en-US" sz="3600" dirty="0" err="1">
+              <a:t>• Results: Sub-second UI updates through reactive streams (</a:t>
+            </a:r>
+            <a:r>
+              <a:rPr sz="3200" b="0" dirty="0" err="1">
                 <a:solidFill>
                   <a:schemeClr val="tx1"/>
                 </a:solidFill>
@@ -3782,28 +3849,23 @@
               <a:t>LiveData</a:t>
             </a:r>
             <a:r>
-              <a:rPr lang="en-US" sz="3600" dirty="0">
+              <a:rPr sz="3200" b="0" dirty="0">
                 <a:solidFill>
                   <a:schemeClr val="tx1"/>
                 </a:solidFill>
               </a:rPr>
-              <a:t>/Flow).</a:t>
-            </a:r>
-          </a:p>
-          <a:p>
-            <a:r>
-              <a:rPr lang="en-US" sz="3600" dirty="0">
+              <a:t> / Flow).</a:t>
+            </a:r>
+          </a:p>
+          <a:p>
+            <a:r>
+              <a:rPr sz="3200" b="0" dirty="0">
                 <a:solidFill>
                   <a:schemeClr val="tx1"/>
                 </a:solidFill>
               </a:rPr>
-              <a:t>• Comparison: Compared to the initial project target of a simple weather display, the final result exceeds requirements by including background workers, advanced Air Quality data, and persistent user favorites using Room.</a:t>
-            </a:r>
-            <a:endParaRPr lang="en-IL" sz="3600" dirty="0">
-              <a:solidFill>
-                <a:schemeClr val="tx1"/>
-              </a:solidFill>
-            </a:endParaRPr>
+              <a:t>• Comparison: Exceeds the initial simple-weather target with background workers, air-quality data, and persistent favorites.</a:t>
+            </a:r>
           </a:p>
         </p:txBody>
       </p:sp>
@@ -3821,8 +3883,8 @@
         </p:nvSpPr>
         <p:spPr>
           <a:xfrm>
-            <a:off x="818147" y="31296930"/>
-            <a:ext cx="13343330" cy="4037428"/>
+            <a:off x="733457" y="31775400"/>
+            <a:ext cx="13343330" cy="3839307"/>
           </a:xfrm>
           <a:prstGeom prst="roundRect">
             <a:avLst/>
@@ -3857,48 +3919,33 @@
           <a:lstStyle/>
           <a:p>
             <a:r>
-              <a:rPr lang="en-US" sz="3600" dirty="0">
+              <a:rPr sz="4000" b="1" dirty="0">
                 <a:solidFill>
                   <a:schemeClr val="tx1"/>
                 </a:solidFill>
               </a:rPr>
-              <a:t>5. </a:t>
-            </a:r>
-            <a:r>
-              <a:rPr lang="en-US" sz="3600" b="1" dirty="0">
+              <a:t>5. Discussions</a:t>
+            </a:r>
+          </a:p>
+          <a:p>
+            <a:r>
+              <a:rPr sz="3200" b="0" dirty="0">
                 <a:solidFill>
                   <a:schemeClr val="tx1"/>
                 </a:solidFill>
               </a:rPr>
-              <a:t>Discussions</a:t>
-            </a:r>
-          </a:p>
-          <a:p>
-            <a:r>
-              <a:rPr lang="en-US" sz="3600" dirty="0">
+              <a:t>• Further Development: Home-screen widgets, severe-weather notifications, and interactive radar maps via Google Maps API.</a:t>
+            </a:r>
+          </a:p>
+          <a:p>
+            <a:r>
+              <a:rPr sz="3200" b="0" dirty="0">
                 <a:solidFill>
                   <a:schemeClr val="tx1"/>
                 </a:solidFill>
               </a:rPr>
-              <a:t>• Further Development: Future iterations will include Home Screen Widgets, severe weather push notifications, and detailed weather maps using Google Maps API.</a:t>
-            </a:r>
-          </a:p>
-          <a:p>
-            <a:r>
-              <a:rPr lang="en-US" sz="3600" dirty="0">
-                <a:solidFill>
-                  <a:schemeClr val="tx1"/>
-                </a:solidFill>
-              </a:rPr>
-              <a:t>◦ [Insert QR Code 1: Link to Project Demo Video]- will be done later</a:t>
-            </a:r>
-          </a:p>
-          <a:p>
-            <a:endParaRPr lang="en-IL" sz="3800" dirty="0">
-              <a:solidFill>
-                <a:schemeClr val="tx1"/>
-              </a:solidFill>
-            </a:endParaRPr>
+              <a:t>• Demo Video: Scan the QR code in the Access section or watch on YouTube: https://www.youtube.com/watch?v=B0h5Y6Pb5s0</a:t>
+            </a:r>
           </a:p>
         </p:txBody>
       </p:sp>
@@ -3917,7 +3964,7 @@
         <p:spPr>
           <a:xfrm>
             <a:off x="14365545" y="31356292"/>
-            <a:ext cx="10016283" cy="4258415"/>
+            <a:ext cx="10437555" cy="4258415"/>
           </a:xfrm>
           <a:prstGeom prst="roundRect">
             <a:avLst/>
@@ -3952,7 +3999,7 @@
           <a:lstStyle/>
           <a:p>
             <a:r>
-              <a:rPr lang="en-US" sz="3800" dirty="0">
+              <a:rPr sz="3800" b="1" dirty="0">
                 <a:solidFill>
                   <a:schemeClr val="tx1"/>
                 </a:solidFill>
@@ -3990,8 +4037,8 @@
         </p:blipFill>
         <p:spPr>
           <a:xfrm>
-            <a:off x="20889978" y="32131266"/>
-            <a:ext cx="3203092" cy="3203092"/>
+            <a:off x="20889978" y="31842507"/>
+            <a:ext cx="3491850" cy="3491850"/>
           </a:xfrm>
           <a:prstGeom prst="rect">
             <a:avLst/>
@@ -4044,7 +4091,7 @@
         </p:nvSpPr>
         <p:spPr>
           <a:xfrm>
-            <a:off x="21000720" y="31577280"/>
+            <a:off x="20889978" y="31311065"/>
             <a:ext cx="2865120" cy="461665"/>
           </a:xfrm>
           <a:prstGeom prst="rect">
@@ -4058,12 +4105,10 @@
           </a:bodyPr>
           <a:lstStyle/>
           <a:p>
-            <a:pPr algn="ctr"/>
-            <a:r>
-              <a:rPr lang="en-US" sz="2400" dirty="0"/>
-              <a:t>GitHub link:</a:t>
-            </a:r>
-            <a:endParaRPr lang="en-IL" sz="2400" dirty="0"/>
+            <a:r>
+              <a:rPr sz="2400" dirty="0"/>
+              <a:t>GitHub </a:t>
+            </a:r>
           </a:p>
         </p:txBody>
       </p:sp>
@@ -4085,6 +4130,77 @@
           <a:xfrm>
             <a:off x="14365545" y="18494895"/>
             <a:ext cx="10016283" cy="12802035"/>
+          </a:xfrm>
+          <a:prstGeom prst="rect">
+            <a:avLst/>
+          </a:prstGeom>
+        </p:spPr>
+      </p:pic>
+      <p:sp>
+        <p:nvSpPr>
+          <p:cNvPr id="10" name="TextBox 9">
+            <a:extLst>
+              <a:ext uri="{FF2B5EF4-FFF2-40B4-BE49-F238E27FC236}">
+                <a16:creationId xmlns:a16="http://schemas.microsoft.com/office/drawing/2014/main" id="{58DC438E-8997-D725-847D-466B5EE98B8A}"/>
+              </a:ext>
+            </a:extLst>
+          </p:cNvPr>
+          <p:cNvSpPr txBox="1"/>
+          <p:nvPr/>
+        </p:nvSpPr>
+        <p:spPr>
+          <a:xfrm>
+            <a:off x="17217525" y="31342157"/>
+            <a:ext cx="2865120" cy="461665"/>
+          </a:xfrm>
+          <a:prstGeom prst="rect">
+            <a:avLst/>
+          </a:prstGeom>
+          <a:noFill/>
+        </p:spPr>
+        <p:txBody>
+          <a:bodyPr wrap="square" rtlCol="0">
+            <a:spAutoFit/>
+          </a:bodyPr>
+          <a:lstStyle/>
+          <a:p>
+            <a:r>
+              <a:rPr sz="2400" dirty="0"/>
+              <a:t>Video</a:t>
+            </a:r>
+          </a:p>
+        </p:txBody>
+      </p:sp>
+      <p:pic>
+        <p:nvPicPr>
+          <p:cNvPr id="14" name="Picture 13">
+            <a:extLst>
+              <a:ext uri="{FF2B5EF4-FFF2-40B4-BE49-F238E27FC236}">
+                <a16:creationId xmlns:a16="http://schemas.microsoft.com/office/drawing/2014/main" id="{21A65628-EFB9-36AC-4D22-DAF57B899CAF}"/>
+              </a:ext>
+            </a:extLst>
+          </p:cNvPr>
+          <p:cNvPicPr>
+            <a:picLocks noChangeAspect="1"/>
+          </p:cNvPicPr>
+          <p:nvPr/>
+        </p:nvPicPr>
+        <p:blipFill>
+          <a:blip r:embed="rId6">
+            <a:extLst>
+              <a:ext uri="{28A0092B-C50C-407E-A947-70E740481C1C}">
+                <a14:useLocalDpi xmlns:a14="http://schemas.microsoft.com/office/drawing/2010/main" val="0"/>
+              </a:ext>
+            </a:extLst>
+          </a:blip>
+          <a:stretch>
+            <a:fillRect/>
+          </a:stretch>
+        </p:blipFill>
+        <p:spPr>
+          <a:xfrm>
+            <a:off x="17217525" y="31839920"/>
+            <a:ext cx="3494437" cy="3494437"/>
           </a:xfrm>
           <a:prstGeom prst="rect">
             <a:avLst/>

</xml_diff>